<commit_message>
feat: Case 2-2 Web recording playback automation complete
- Smart language switching to Traditional Chinese

- Smart waiting for View tab, Server, and Camera

- Multi-strategy XPath for stability

- Timeline green block click and pause button

- Browser auto-maximize and bring to front
</commit_message>
<xml_diff>
--- a/Automation_Framework_Presentation.pptx
+++ b/Automation_Framework_Presentation.pptx
@@ -4580,21 +4580,35 @@
               <a:defRPr sz="2400"/>
             </a:pPr>
             <a:r>
-              <a:t>解決「定位失敗」的多層級保底策略：</a:t>
+              <a:rPr dirty="0" err="1"/>
+              <a:t>解決「定位失敗」的多層級保底策略</a:t>
+            </a:r>
+            <a:r>
+              <a:rPr dirty="0"/>
+              <a:t>：</a:t>
             </a:r>
           </a:p>
           <a:p>
             <a:pPr>
               <a:defRPr sz="2400"/>
             </a:pPr>
-            <a:endParaRPr/>
+            <a:endParaRPr dirty="0"/>
           </a:p>
           <a:p>
             <a:pPr>
               <a:defRPr sz="2400"/>
             </a:pPr>
             <a:r>
-              <a:t>Level 1: AI 視覺理解 (VLM)</a:t>
+              <a:rPr dirty="0"/>
+              <a:t>Level 1: AI </a:t>
+            </a:r>
+            <a:r>
+              <a:rPr dirty="0" err="1"/>
+              <a:t>視覺理解</a:t>
+            </a:r>
+            <a:r>
+              <a:rPr dirty="0"/>
+              <a:t> (VLM)</a:t>
             </a:r>
           </a:p>
           <a:p>
@@ -4602,15 +4616,62 @@
               <a:defRPr sz="2400"/>
             </a:pPr>
             <a:r>
-              <a:t>使用本地大模型 (Ollama/LLaVA) 理解自然語言</a:t>
-            </a:r>
+              <a:rPr dirty="0" err="1"/>
+              <a:t>使用本地大模型</a:t>
+            </a:r>
+            <a:r>
+              <a:rPr dirty="0"/>
+              <a:t> (</a:t>
+            </a:r>
+            <a:r>
+              <a:rPr dirty="0" err="1"/>
+              <a:t>Ollama</a:t>
+            </a:r>
+            <a:r>
+              <a:rPr dirty="0"/>
+              <a:t>/</a:t>
+            </a:r>
+            <a:r>
+              <a:rPr dirty="0" err="1"/>
+              <a:t>LLaVA</a:t>
+            </a:r>
+            <a:r>
+              <a:rPr dirty="0"/>
+              <a:t>) </a:t>
+            </a:r>
+            <a:r>
+              <a:rPr dirty="0" err="1"/>
+              <a:t>理解自然語言</a:t>
+            </a:r>
+            <a:endParaRPr dirty="0"/>
           </a:p>
           <a:p>
             <a:pPr>
               <a:defRPr sz="2400"/>
             </a:pPr>
             <a:r>
-              <a:t>Level 2: 圖像特徵比對 (OpenCV)</a:t>
+              <a:rPr dirty="0"/>
+              <a:t>Level 2: </a:t>
+            </a:r>
+            <a:r>
+              <a:rPr dirty="0" err="1"/>
+              <a:t>圖像特徵比對</a:t>
+            </a:r>
+            <a:r>
+              <a:rPr dirty="0"/>
+              <a:t> (</a:t>
+            </a:r>
+            <a:r>
+              <a:rPr dirty="0" err="1"/>
+              <a:t>O</a:t>
+            </a:r>
+            <a:r>
+              <a:rPr lang="en-US" altLang="zh-CN" dirty="0" err="1"/>
+              <a:t>kScript</a:t>
+            </a:r>
+            <a:r>
+              <a:rPr dirty="0"/>
+              <a:t>)</a:t>
             </a:r>
           </a:p>
           <a:p>
@@ -4618,7 +4679,24 @@
               <a:defRPr sz="2400"/>
             </a:pPr>
             <a:r>
-              <a:t>Level 3: OCR 文字辨識 (PaddleOCR)</a:t>
+              <a:rPr dirty="0"/>
+              <a:t>Level 3: OCR </a:t>
+            </a:r>
+            <a:r>
+              <a:rPr dirty="0" err="1"/>
+              <a:t>文字辨識</a:t>
+            </a:r>
+            <a:r>
+              <a:rPr dirty="0"/>
+              <a:t> (</a:t>
+            </a:r>
+            <a:r>
+              <a:rPr dirty="0" err="1"/>
+              <a:t>PaddleOCR</a:t>
+            </a:r>
+            <a:r>
+              <a:rPr dirty="0"/>
+              <a:t>)</a:t>
             </a:r>
           </a:p>
           <a:p>
@@ -4626,7 +4704,16 @@
               <a:defRPr sz="2400"/>
             </a:pPr>
             <a:r>
-              <a:t>Level 4: 自學習座標保底 (Coordinate Fallback)</a:t>
+              <a:rPr dirty="0"/>
+              <a:t>Level 4: </a:t>
+            </a:r>
+            <a:r>
+              <a:rPr dirty="0" err="1"/>
+              <a:t>自學習座標保底</a:t>
+            </a:r>
+            <a:r>
+              <a:rPr dirty="0"/>
+              <a:t> (Coordinate Fallback)</a:t>
             </a:r>
           </a:p>
         </p:txBody>
@@ -4696,21 +4783,43 @@
               <a:defRPr sz="2400"/>
             </a:pPr>
             <a:r>
-              <a:t>HTML 互動式報告 (類似 Allure/UFT)：</a:t>
+              <a:rPr dirty="0"/>
+              <a:t>HTML </a:t>
+            </a:r>
+            <a:r>
+              <a:rPr dirty="0" err="1"/>
+              <a:t>互動式報告</a:t>
+            </a:r>
+            <a:r>
+              <a:rPr dirty="0"/>
+              <a:t> (</a:t>
+            </a:r>
+            <a:r>
+              <a:rPr dirty="0" err="1"/>
+              <a:t>類似</a:t>
+            </a:r>
+            <a:r>
+              <a:rPr dirty="0"/>
+              <a:t> Allure/UFT)：</a:t>
             </a:r>
           </a:p>
           <a:p>
             <a:pPr>
               <a:defRPr sz="2400"/>
             </a:pPr>
-            <a:endParaRPr/>
+            <a:endParaRPr dirty="0"/>
           </a:p>
           <a:p>
             <a:pPr>
               <a:defRPr sz="2400"/>
             </a:pPr>
             <a:r>
-              <a:t>智慧標註截圖：</a:t>
+              <a:rPr dirty="0" err="1"/>
+              <a:t>智慧標註截圖</a:t>
+            </a:r>
+            <a:r>
+              <a:rPr dirty="0"/>
+              <a:t>：</a:t>
             </a:r>
           </a:p>
           <a:p>
@@ -4718,23 +4827,48 @@
               <a:defRPr sz="2400"/>
             </a:pPr>
             <a:r>
-              <a:t>自動繪製紅框/綠框，標示 AI 識別位置</a:t>
-            </a:r>
+              <a:rPr dirty="0" err="1"/>
+              <a:t>自動繪製紅框</a:t>
+            </a:r>
+            <a:r>
+              <a:rPr dirty="0"/>
+              <a:t>/</a:t>
+            </a:r>
+            <a:r>
+              <a:rPr dirty="0" err="1"/>
+              <a:t>綠框，標示</a:t>
+            </a:r>
+            <a:r>
+              <a:rPr dirty="0"/>
+              <a:t> AI </a:t>
+            </a:r>
+            <a:r>
+              <a:rPr dirty="0" err="1"/>
+              <a:t>識別位置</a:t>
+            </a:r>
+            <a:endParaRPr dirty="0"/>
           </a:p>
           <a:p>
             <a:pPr lvl="1">
               <a:defRPr sz="2400"/>
             </a:pPr>
             <a:r>
+              <a:rPr dirty="0" err="1"/>
               <a:t>展示「預期點擊」與「實際識別」差異</a:t>
             </a:r>
+            <a:endParaRPr dirty="0"/>
           </a:p>
           <a:p>
             <a:pPr>
               <a:defRPr sz="2400"/>
             </a:pPr>
             <a:r>
-              <a:t>失敗現場還原：</a:t>
+              <a:rPr dirty="0" err="1"/>
+              <a:t>失敗現場還原</a:t>
+            </a:r>
+            <a:r>
+              <a:rPr dirty="0"/>
+              <a:t>：</a:t>
             </a:r>
           </a:p>
           <a:p>
@@ -4742,11 +4876,51 @@
               <a:defRPr sz="2400"/>
             </a:pPr>
             <a:r>
-              <a:t>自動保存 Terminal Log 與全螢幕截圖</a:t>
-            </a:r>
-          </a:p>
-        </p:txBody>
-      </p:sp>
+              <a:rPr dirty="0" err="1"/>
+              <a:t>自動保存</a:t>
+            </a:r>
+            <a:r>
+              <a:rPr dirty="0"/>
+              <a:t> Terminal Log </a:t>
+            </a:r>
+            <a:r>
+              <a:rPr dirty="0" err="1"/>
+              <a:t>與全螢幕截圖</a:t>
+            </a:r>
+            <a:endParaRPr dirty="0"/>
+          </a:p>
+        </p:txBody>
+      </p:sp>
+      <p:pic>
+        <p:nvPicPr>
+          <p:cNvPr id="5" name="圖片 4" descr="一張含有 文字, 螢幕擷取畫面, 多媒體軟體, 軟體 的圖片&#10;&#10;AI 產生的內容可能不正確。">
+            <a:extLst>
+              <a:ext uri="{FF2B5EF4-FFF2-40B4-BE49-F238E27FC236}">
+                <a16:creationId xmlns:a16="http://schemas.microsoft.com/office/drawing/2014/main" id="{29585844-BC22-C36C-B99A-2C38B6568EC9}"/>
+              </a:ext>
+            </a:extLst>
+          </p:cNvPr>
+          <p:cNvPicPr>
+            <a:picLocks noChangeAspect="1"/>
+          </p:cNvPicPr>
+          <p:nvPr/>
+        </p:nvPicPr>
+        <p:blipFill>
+          <a:blip r:embed="rId2"/>
+          <a:stretch>
+            <a:fillRect/>
+          </a:stretch>
+        </p:blipFill>
+        <p:spPr>
+          <a:xfrm>
+            <a:off x="6444188" y="1957151"/>
+            <a:ext cx="1922572" cy="2471017"/>
+          </a:xfrm>
+          <a:prstGeom prst="rect">
+            <a:avLst/>
+          </a:prstGeom>
+        </p:spPr>
+      </p:pic>
     </p:spTree>
   </p:cSld>
   <p:clrMapOvr>
@@ -4812,21 +4986,36 @@
               <a:defRPr sz="2400"/>
             </a:pPr>
             <a:r>
+              <a:rPr dirty="0" err="1"/>
               <a:t>讓自動化觸手可及</a:t>
             </a:r>
+            <a:endParaRPr dirty="0"/>
           </a:p>
           <a:p>
             <a:pPr>
               <a:defRPr sz="2400"/>
             </a:pPr>
-            <a:endParaRPr/>
+            <a:endParaRPr dirty="0"/>
           </a:p>
           <a:p>
             <a:pPr>
               <a:defRPr sz="2400"/>
             </a:pPr>
             <a:r>
-              <a:t>Tkinter GUI 工具 (test_case_launcher.py)：</a:t>
+              <a:rPr dirty="0" err="1"/>
+              <a:t>Tkinter</a:t>
+            </a:r>
+            <a:r>
+              <a:rPr dirty="0"/>
+              <a:t> GUI </a:t>
+            </a:r>
+            <a:r>
+              <a:rPr dirty="0" err="1"/>
+              <a:t>工具</a:t>
+            </a:r>
+            <a:r>
+              <a:rPr dirty="0"/>
+              <a:t> (test_case_launcher.py)：</a:t>
             </a:r>
           </a:p>
           <a:p>
@@ -4834,31 +5023,50 @@
               <a:defRPr sz="2400"/>
             </a:pPr>
             <a:r>
-              <a:t>自動掃描 Excel 測試計畫</a:t>
-            </a:r>
+              <a:rPr dirty="0" err="1"/>
+              <a:t>自動掃描</a:t>
+            </a:r>
+            <a:r>
+              <a:rPr dirty="0"/>
+              <a:t> Excel </a:t>
+            </a:r>
+            <a:r>
+              <a:rPr dirty="0" err="1"/>
+              <a:t>測試計畫</a:t>
+            </a:r>
+            <a:endParaRPr dirty="0"/>
           </a:p>
           <a:p>
             <a:pPr lvl="1">
               <a:defRPr sz="2400"/>
             </a:pPr>
             <a:r>
+              <a:rPr dirty="0" err="1"/>
               <a:t>勾選介面，支援批量執行</a:t>
             </a:r>
+            <a:endParaRPr dirty="0"/>
           </a:p>
           <a:p>
             <a:pPr lvl="1">
               <a:defRPr sz="2400"/>
             </a:pPr>
             <a:r>
+              <a:rPr dirty="0" err="1"/>
               <a:t>多執行緒設計，介面不卡頓</a:t>
             </a:r>
+            <a:endParaRPr dirty="0"/>
           </a:p>
           <a:p>
             <a:pPr>
               <a:defRPr sz="2400"/>
             </a:pPr>
             <a:r>
-              <a:t>部署優勢：</a:t>
+              <a:rPr dirty="0" err="1"/>
+              <a:t>部署優勢</a:t>
+            </a:r>
+            <a:r>
+              <a:rPr dirty="0"/>
+              <a:t>：</a:t>
             </a:r>
           </a:p>
           <a:p>
@@ -4866,11 +5074,59 @@
               <a:defRPr sz="2400"/>
             </a:pPr>
             <a:r>
-              <a:t>可打包為 .exe，無 Python 環境也能執行</a:t>
-            </a:r>
-          </a:p>
-        </p:txBody>
-      </p:sp>
+              <a:rPr dirty="0" err="1"/>
+              <a:t>可打包為</a:t>
+            </a:r>
+            <a:r>
+              <a:rPr dirty="0"/>
+              <a:t> .</a:t>
+            </a:r>
+            <a:r>
+              <a:rPr dirty="0" err="1"/>
+              <a:t>exe，無</a:t>
+            </a:r>
+            <a:r>
+              <a:rPr dirty="0"/>
+              <a:t> Python </a:t>
+            </a:r>
+            <a:r>
+              <a:rPr dirty="0" err="1"/>
+              <a:t>環境也能執行</a:t>
+            </a:r>
+            <a:endParaRPr dirty="0"/>
+          </a:p>
+        </p:txBody>
+      </p:sp>
+      <p:pic>
+        <p:nvPicPr>
+          <p:cNvPr id="5" name="圖片 4" descr="一張含有 文字, 電子產品, 螢幕擷取畫面, 陳列 的圖片&#10;&#10;AI 產生的內容可能不正確。">
+            <a:extLst>
+              <a:ext uri="{FF2B5EF4-FFF2-40B4-BE49-F238E27FC236}">
+                <a16:creationId xmlns:a16="http://schemas.microsoft.com/office/drawing/2014/main" id="{0CC9193C-1DDE-1151-C57B-779E46D810DA}"/>
+              </a:ext>
+            </a:extLst>
+          </p:cNvPr>
+          <p:cNvPicPr>
+            <a:picLocks noChangeAspect="1"/>
+          </p:cNvPicPr>
+          <p:nvPr/>
+        </p:nvPicPr>
+        <p:blipFill>
+          <a:blip r:embed="rId2"/>
+          <a:stretch>
+            <a:fillRect/>
+          </a:stretch>
+        </p:blipFill>
+        <p:spPr>
+          <a:xfrm>
+            <a:off x="6322142" y="2805199"/>
+            <a:ext cx="2191303" cy="2022439"/>
+          </a:xfrm>
+          <a:prstGeom prst="rect">
+            <a:avLst/>
+          </a:prstGeom>
+        </p:spPr>
+      </p:pic>
     </p:spTree>
   </p:cSld>
   <p:clrMapOvr>

</xml_diff>